<commit_message>
docs(tv1): dong bo rang buoc tuoi DATEADD, actual plan benchmark va phan dinh pham vi anh lich su
</commit_message>
<xml_diff>
--- a/Bo_nop_Nhom06/evidence/TV1/TV1_Slides_1-3.pptx
+++ b/Bo_nop_Nhom06/evidence/TV1/TV1_Slides_1-3.pptx
@@ -693,7 +693,7 @@
           </a:p>
           <a:p>
             <a:r>
-              <a:t>Tiếp theo là phần đối tượng lập trình SQL và tối ưu hóa hiệu năng. Giao diện NhanVienPanel gọi qua NhanVienService và NhanVienDAO để tương tác với CSDL. Khi thêm nhân viên, procedure sp_ThemNhanVien thực hiện trong một TRANSACTION nguyên tử: nếu tài khoản bị trùng username, hệ thống tự động ROLLBACK toàn bộ hồ sơ nhân viên vừa thêm, không để lại dữ liệu rác. Trigger trg_NhanVien_KhongXoaKhiDaPhatSinhLuong bảo vệ dữ liệu bằng cách chặn xóa cứng nếu nhân viên đã có công hoặc lương, buộc chuyển sang Soft Delete. Về chỉ mục, em đã đánh Covering Index IX_NHANVIEN_HoTen kèm mệnh đề INCLUDE 5 cột cần hiển thị. Kết quả benchmark trên fixture 5.000 dòng đo lường thực tế trên SQL Server cho thấy số logical reads giảm từ 75 xuống còn 10, tức giảm 86.67% chi phí đọc I/O và triệt tiêu 100% thao tác Key Lookup.</a:t>
+              <a:t>Tiếp theo là phần đối tượng lập trình SQL và tối ưu hóa hiệu năng. Giao diện NhanVienPanel gọi qua NhanVienService và NhanVienDAO để tương tác với CSDL. Ràng buộc tuổi hiện hành là NgaySinh &lt;= DATEADD(YEAR,-18,NgayVaoLam) kiểm tra chính xác đến ngày sinh nhật, đã qua kiểm thử 9 ca biên trong TV1_Age_Boundaries.sql. Khi thêm nhân viên, procedure sp_ThemNhanVien thực hiện trong TRANSACTION nguyên tử: nếu trùng tài khoản, hệ thống tự động ROLLBACK toàn bộ hồ sơ vừa thêm, không để lại dữ liệu rác. Trigger trg_NhanVien_KhongXoaKhiDaPhatSinhLuong chặn xóa cứng khi đã có công hoặc lương, buộc Soft Delete. Về chỉ mục, em đã đánh Covering Index IX_NHANVIEN_HoTen kèm INCLUDE 5 cột. Kết quả đo lường thực tế trên fixture 5.000 dòng ghi nhận logical reads giảm từ 75 xuống 10 (giảm 86.67% I/O), triệt tiêu Key Lookup, có log và Actual Plan TV1_Benchmark_ActualPlan.sqlplan đi kèm.</a:t>
             </a:r>
           </a:p>
         </p:txBody>
@@ -5147,7 +5147,7 @@
                 </a:solidFill>
                 <a:latin typeface="Segoe UI"/>
               </a:rPr>
-              <a:t>Ràng buộc toàn vẹn: Tuổi lao động &gt;= 18 · CCCD 12 số · SĐT 10 số · Lương &gt; 0</a:t>
+              <a:t>Ràng buộc toàn vẹn: NgaySinh &lt;= DATEADD(YEAR,-18,NgayVaoLam) · CCCD 12 số · Lương &gt; 0</a:t>
             </a:r>
             <a:endParaRPr lang="en-US" sz="1900" b="1">
               <a:solidFill>
@@ -7712,7 +7712,7 @@
                 </a:solidFill>
                 <a:latin typeface="Segoe UI"/>
               </a:rPr>
-              <a:t>INTEGRATION TEST TV1</a:t>
+              <a:t>INTEGRATION &amp; BIÊN TUỔI</a:t>
             </a:r>
           </a:p>
         </p:txBody>
@@ -7752,7 +7752,7 @@
                 </a:solidFill>
                 <a:latin typeface="Segoe UI"/>
               </a:rPr>
-              <a:t>7/7 PASS</a:t>
+              <a:t>7/7 + 9/9</a:t>
             </a:r>
           </a:p>
         </p:txBody>
@@ -7792,7 +7792,7 @@
                 </a:solidFill>
                 <a:latin typeface="Segoe UI"/>
               </a:rPr>
-              <a:t>QA SQL 2025 · test_module_nhansu_TV1</a:t>
+              <a:t>QA SQL 2025 · test_module_nhansu_TV1 · TV1_Age_Boundaries</a:t>
             </a:r>
           </a:p>
         </p:txBody>
@@ -8009,7 +8009,7 @@
                 </a:solidFill>
                 <a:latin typeface="Segoe UI"/>
               </a:rPr>
-              <a:t>Covering Index Seek (giảm 86.67% I/O) · Triệt tiêu 100% Key Lookup · 500 dòng</a:t>
+              <a:t>Covering Seek (giảm 86.67% I/O) · Bằng chứng: log &amp; ActualPlan.sqlplan</a:t>
             </a:r>
           </a:p>
         </p:txBody>
@@ -8119,7 +8119,7 @@
                 </a:solidFill>
                 <a:latin typeface="Segoe UI"/>
               </a:rPr>
-              <a:t>TRANSACTION ROLLBACK &amp; TRIGGER SOFT DELETE</a:t>
+              <a:t>TRANSACTION ROLLBACK &amp; RÀNG BUỘC TUỔI BIRTHDAY-AWARE</a:t>
             </a:r>
           </a:p>
         </p:txBody>
@@ -8199,7 +8199,7 @@
                 </a:solidFill>
                 <a:latin typeface="Segoe UI"/>
               </a:rPr>
-              <a:t>trg_NhanVien_KhongXoaKhiDaPhatSinhLuong: Chặn xóa cứng khi đã có công/lương → Buộc Soft Delete.</a:t>
+              <a:t>Ràng buộc tuổi: NgaySinh &lt;= DATEADD(YEAR,-18,NgayVaoLam) kiểm tra sinh nhật · Trigger chặn xóa cứng.</a:t>
             </a:r>
           </a:p>
         </p:txBody>

</xml_diff>